<commit_message>
Add v3 ablation results and update GMUG slides with actual data
Cardinal job 8422821 completed (10h36m): all 6 ablation configs
across 20 variants, 867K conditions. Key findings:

- Full v3 model: BA R2 0.703 vs 0.689 default (+2.0%), RMSE 28.86 vs 29.64
- Ingrowth is the dominant component (+7.0% BA RMSE when removed)
- Median DG (v3) outperforms Baskerville mean (v2): BA RMSE 28.86 vs 29.08
- ClimateSI and SDImax contribute <0.1% at 6.5-year horizons (expected
  to matter at longer projection periods)

GMUG slides updated with actual v3 numbers, ablation percentages,
and refined messaging reflecting component contribution analysis.

Co-Authored-By: Claude Opus 4.6 <noreply@anthropic.com>
</commit_message>
<xml_diff>
--- a/calibration/slides/gmug_aaron_slides.pptx
+++ b/calibration/slides/gmug_aaron_slides.pptx
@@ -1988,7 +1988,7 @@
                 <a:ea typeface="Georgia" pitchFamily="34" charset="-122"/>
                 <a:cs typeface="Georgia" pitchFamily="34" charset="-120"/>
               </a:rPr>
-              <a:t>Bayesian Calibration: 22-Variant Benchmark</a:t>
+              <a:t>Bayesian Calibration: v3 Ablation Results</a:t>
             </a:r>
             <a:endParaRPr lang="en-US" sz="2200" dirty="0"/>
           </a:p>
@@ -2105,7 +2105,7 @@
                 <a:ea typeface="Calibri" pitchFamily="34" charset="-122"/>
                 <a:cs typeface="Calibri" pitchFamily="34" charset="-120"/>
               </a:rPr>
-              <a:t>What we built as a bridge to FVS-CONUS</a:t>
+              <a:t>22-variant benchmark across 867K conditions, 16.2M FIA tree records</a:t>
             </a:r>
             <a:endParaRPr lang="en-US" sz="1300" dirty="0"/>
           </a:p>
@@ -2169,7 +2169,7 @@
                 <a:ea typeface="Georgia" pitchFamily="34" charset="-122"/>
                 <a:cs typeface="Georgia" pitchFamily="34" charset="-120"/>
               </a:rPr>
-              <a:t>25</a:t>
+              <a:t>20</a:t>
             </a:r>
             <a:endParaRPr lang="en-US" sz="2800" dirty="0"/>
           </a:p>
@@ -2225,7 +2225,7 @@
                 <a:ea typeface="Calibri" pitchFamily="34" charset="-122"/>
                 <a:cs typeface="Calibri" pitchFamily="34" charset="-120"/>
               </a:rPr>
-              <a:t>Calibrated</a:t>
+              <a:t>Benchmarked</a:t>
             </a:r>
             <a:endParaRPr lang="en-US" sz="1000" dirty="0"/>
           </a:p>
@@ -2289,7 +2289,7 @@
                 <a:ea typeface="Georgia" pitchFamily="34" charset="-122"/>
                 <a:cs typeface="Georgia" pitchFamily="34" charset="-120"/>
               </a:rPr>
-              <a:t>16.2M</a:t>
+              <a:t>867K</a:t>
             </a:r>
             <a:endParaRPr lang="en-US" sz="2800" dirty="0"/>
           </a:p>
@@ -2328,7 +2328,7 @@
                 <a:ea typeface="Calibri" pitchFamily="34" charset="-122"/>
                 <a:cs typeface="Calibri" pitchFamily="34" charset="-120"/>
               </a:rPr>
-              <a:t>FIA Tree</a:t>
+              <a:t>Stand</a:t>
             </a:r>
             <a:endParaRPr lang="en-US" sz="1000" dirty="0"/>
           </a:p>
@@ -2345,7 +2345,7 @@
                 <a:ea typeface="Calibri" pitchFamily="34" charset="-122"/>
                 <a:cs typeface="Calibri" pitchFamily="34" charset="-120"/>
               </a:rPr>
-              <a:t>Records</a:t>
+              <a:t>Conditions</a:t>
             </a:r>
             <a:endParaRPr lang="en-US" sz="1000" dirty="0"/>
           </a:p>
@@ -2409,7 +2409,7 @@
                 <a:ea typeface="Georgia" pitchFamily="34" charset="-122"/>
                 <a:cs typeface="Georgia" pitchFamily="34" charset="-120"/>
               </a:rPr>
-              <a:t>435K</a:t>
+              <a:t>6.5 yr</a:t>
             </a:r>
             <a:endParaRPr lang="en-US" sz="2800" dirty="0"/>
           </a:p>
@@ -2448,7 +2448,7 @@
                 <a:ea typeface="Calibri" pitchFamily="34" charset="-122"/>
                 <a:cs typeface="Calibri" pitchFamily="34" charset="-120"/>
               </a:rPr>
-              <a:t>Stand</a:t>
+              <a:t>Avg Remeasure</a:t>
             </a:r>
             <a:endParaRPr lang="en-US" sz="1000" dirty="0"/>
           </a:p>
@@ -2465,7 +2465,7 @@
                 <a:ea typeface="Calibri" pitchFamily="34" charset="-122"/>
                 <a:cs typeface="Calibri" pitchFamily="34" charset="-120"/>
               </a:rPr>
-              <a:t>Conditions</a:t>
+              <a:t>Interval</a:t>
             </a:r>
             <a:endParaRPr lang="en-US" sz="1000" dirty="0"/>
           </a:p>
@@ -2529,7 +2529,7 @@
                 <a:ea typeface="Georgia" pitchFamily="34" charset="-122"/>
                 <a:cs typeface="Georgia" pitchFamily="34" charset="-120"/>
               </a:rPr>
-              <a:t>6.5 yr</a:t>
+              <a:t>+2.0%</a:t>
             </a:r>
             <a:endParaRPr lang="en-US" sz="2800" dirty="0"/>
           </a:p>
@@ -2568,7 +2568,7 @@
                 <a:ea typeface="Calibri" pitchFamily="34" charset="-122"/>
                 <a:cs typeface="Calibri" pitchFamily="34" charset="-120"/>
               </a:rPr>
-              <a:t>Avg Remeasure</a:t>
+              <a:t>BA R²</a:t>
             </a:r>
             <a:endParaRPr lang="en-US" sz="1000" dirty="0"/>
           </a:p>
@@ -2585,7 +2585,7 @@
                 <a:ea typeface="Calibri" pitchFamily="34" charset="-122"/>
                 <a:cs typeface="Calibri" pitchFamily="34" charset="-120"/>
               </a:rPr>
-              <a:t>Interval</a:t>
+              <a:t>Improvement</a:t>
             </a:r>
             <a:endParaRPr lang="en-US" sz="1000" dirty="0"/>
           </a:p>
@@ -2664,7 +2664,7 @@
                     <a:bodyPr/>
                     <a:lstStyle/>
                     <a:p>
-                      <a:pPr indent="0" marL="0">
+                      <a:pPr algn="l" indent="0" marL="0">
                         <a:buNone/>
                       </a:pPr>
                       <a:r>
@@ -2812,7 +2812,7 @@
                           <a:ea typeface="Calibri" pitchFamily="34" charset="-122"/>
                           <a:cs typeface="Calibri" pitchFamily="34" charset="-120"/>
                         </a:rPr>
-                        <a:t>Calibrated</a:t>
+                        <a:t>Calibrated (v3)</a:t>
                       </a:r>
                       <a:endParaRPr lang="en-US" sz="1100" dirty="0">
                         <a:latin typeface="Calibri" charset="0"/>
@@ -2938,13 +2938,13 @@
                     <a:bodyPr/>
                     <a:lstStyle/>
                     <a:p>
-                      <a:pPr indent="0" marL="0">
+                      <a:pPr algn="ctr" indent="0" marL="0">
                         <a:buNone/>
                       </a:pPr>
                       <a:r>
                         <a:rPr lang="en-US" sz="1100" dirty="0">
                           <a:solidFill>
-                            <a:srgbClr val="000000"/>
+                            <a:srgbClr val="1E2A3A"/>
                           </a:solidFill>
                           <a:latin typeface="Calibri" pitchFamily="34" charset="0"/>
                           <a:ea typeface="Calibri" pitchFamily="34" charset="-122"/>
@@ -3009,13 +3009,13 @@
                       <a:r>
                         <a:rPr lang="en-US" sz="1100" dirty="0">
                           <a:solidFill>
-                            <a:srgbClr val="000000"/>
+                            <a:srgbClr val="1E2A3A"/>
                           </a:solidFill>
                           <a:latin typeface="Calibri" pitchFamily="34" charset="0"/>
                           <a:ea typeface="Calibri" pitchFamily="34" charset="-122"/>
                           <a:cs typeface="Calibri" pitchFamily="34" charset="-120"/>
                         </a:rPr>
-                        <a:t>0.672</a:t>
+                        <a:t>0.689</a:t>
                       </a:r>
                       <a:endParaRPr lang="en-US" sz="1100" dirty="0">
                         <a:latin typeface="Calibri" charset="0"/>
@@ -3080,7 +3080,7 @@
                           <a:ea typeface="Calibri" pitchFamily="34" charset="-122"/>
                           <a:cs typeface="Calibri" pitchFamily="34" charset="-120"/>
                         </a:rPr>
-                        <a:t>0.699</a:t>
+                        <a:t>0.703</a:t>
                       </a:r>
                       <a:endParaRPr lang="en-US" sz="1100" dirty="0">
                         <a:latin typeface="Calibri" charset="0"/>
@@ -3145,7 +3145,7 @@
                           <a:ea typeface="Calibri" pitchFamily="34" charset="-122"/>
                           <a:cs typeface="Calibri" pitchFamily="34" charset="-120"/>
                         </a:rPr>
-                        <a:t>+4.0%</a:t>
+                        <a:t>+2.0%</a:t>
                       </a:r>
                       <a:endParaRPr lang="en-US" sz="1100" dirty="0">
                         <a:latin typeface="Calibri" charset="0"/>
@@ -3200,13 +3200,13 @@
                     <a:bodyPr/>
                     <a:lstStyle/>
                     <a:p>
-                      <a:pPr indent="0" marL="0">
+                      <a:pPr algn="ctr" indent="0" marL="0">
                         <a:buNone/>
                       </a:pPr>
                       <a:r>
                         <a:rPr lang="en-US" sz="1100" dirty="0">
                           <a:solidFill>
-                            <a:srgbClr val="000000"/>
+                            <a:srgbClr val="1E2A3A"/>
                           </a:solidFill>
                           <a:latin typeface="Calibri" pitchFamily="34" charset="0"/>
                           <a:ea typeface="Calibri" pitchFamily="34" charset="-122"/>
@@ -3271,13 +3271,13 @@
                       <a:r>
                         <a:rPr lang="en-US" sz="1100" dirty="0">
                           <a:solidFill>
-                            <a:srgbClr val="000000"/>
+                            <a:srgbClr val="1E2A3A"/>
                           </a:solidFill>
                           <a:latin typeface="Calibri" pitchFamily="34" charset="0"/>
                           <a:ea typeface="Calibri" pitchFamily="34" charset="-122"/>
                           <a:cs typeface="Calibri" pitchFamily="34" charset="-120"/>
                         </a:rPr>
-                        <a:t>31.8</a:t>
+                        <a:t>29.6</a:t>
                       </a:r>
                       <a:endParaRPr lang="en-US" sz="1100" dirty="0">
                         <a:latin typeface="Calibri" charset="0"/>
@@ -3342,7 +3342,7 @@
                           <a:ea typeface="Calibri" pitchFamily="34" charset="-122"/>
                           <a:cs typeface="Calibri" pitchFamily="34" charset="-120"/>
                         </a:rPr>
-                        <a:t>30.2</a:t>
+                        <a:t>28.9</a:t>
                       </a:r>
                       <a:endParaRPr lang="en-US" sz="1100" dirty="0">
                         <a:latin typeface="Calibri" charset="0"/>
@@ -3407,7 +3407,7 @@
                           <a:ea typeface="Calibri" pitchFamily="34" charset="-122"/>
                           <a:cs typeface="Calibri" pitchFamily="34" charset="-120"/>
                         </a:rPr>
-                        <a:t>−5.0%</a:t>
+                        <a:t>−2.7%</a:t>
                       </a:r>
                       <a:endParaRPr lang="en-US" sz="1100" dirty="0">
                         <a:latin typeface="Calibri" charset="0"/>
@@ -3462,19 +3462,19 @@
                     <a:bodyPr/>
                     <a:lstStyle/>
                     <a:p>
-                      <a:pPr indent="0" marL="0">
+                      <a:pPr algn="ctr" indent="0" marL="0">
                         <a:buNone/>
                       </a:pPr>
                       <a:r>
                         <a:rPr lang="en-US" sz="1100" dirty="0">
                           <a:solidFill>
-                            <a:srgbClr val="000000"/>
+                            <a:srgbClr val="1E2A3A"/>
                           </a:solidFill>
                           <a:latin typeface="Calibri" pitchFamily="34" charset="0"/>
                           <a:ea typeface="Calibri" pitchFamily="34" charset="-122"/>
                           <a:cs typeface="Calibri" pitchFamily="34" charset="-120"/>
                         </a:rPr>
-                        <a:t>Volume (CFGRS) R²</a:t>
+                        <a:t>SDI R²</a:t>
                       </a:r>
                       <a:endParaRPr lang="en-US" sz="1100" dirty="0">
                         <a:latin typeface="Calibri" charset="0"/>
@@ -3533,13 +3533,13 @@
                       <a:r>
                         <a:rPr lang="en-US" sz="1100" dirty="0">
                           <a:solidFill>
-                            <a:srgbClr val="000000"/>
+                            <a:srgbClr val="1E2A3A"/>
                           </a:solidFill>
                           <a:latin typeface="Calibri" pitchFamily="34" charset="0"/>
                           <a:ea typeface="Calibri" pitchFamily="34" charset="-122"/>
                           <a:cs typeface="Calibri" pitchFamily="34" charset="-120"/>
                         </a:rPr>
-                        <a:t>0.783</a:t>
+                        <a:t>0.625</a:t>
                       </a:r>
                       <a:endParaRPr lang="en-US" sz="1100" dirty="0">
                         <a:latin typeface="Calibri" charset="0"/>
@@ -3604,7 +3604,7 @@
                           <a:ea typeface="Calibri" pitchFamily="34" charset="-122"/>
                           <a:cs typeface="Calibri" pitchFamily="34" charset="-120"/>
                         </a:rPr>
-                        <a:t>0.818</a:t>
+                        <a:t>0.647</a:t>
                       </a:r>
                       <a:endParaRPr lang="en-US" sz="1100" dirty="0">
                         <a:latin typeface="Calibri" charset="0"/>
@@ -3669,7 +3669,7 @@
                           <a:ea typeface="Calibri" pitchFamily="34" charset="-122"/>
                           <a:cs typeface="Calibri" pitchFamily="34" charset="-120"/>
                         </a:rPr>
-                        <a:t>+4.5%</a:t>
+                        <a:t>+3.5%</a:t>
                       </a:r>
                       <a:endParaRPr lang="en-US" sz="1100" dirty="0">
                         <a:latin typeface="Calibri" charset="0"/>
@@ -3724,19 +3724,19 @@
                     <a:bodyPr/>
                     <a:lstStyle/>
                     <a:p>
-                      <a:pPr indent="0" marL="0">
+                      <a:pPr algn="ctr" indent="0" marL="0">
                         <a:buNone/>
                       </a:pPr>
                       <a:r>
                         <a:rPr lang="en-US" sz="1100" dirty="0">
                           <a:solidFill>
-                            <a:srgbClr val="000000"/>
+                            <a:srgbClr val="1E2A3A"/>
                           </a:solidFill>
                           <a:latin typeface="Calibri" pitchFamily="34" charset="0"/>
                           <a:ea typeface="Calibri" pitchFamily="34" charset="-122"/>
                           <a:cs typeface="Calibri" pitchFamily="34" charset="-120"/>
                         </a:rPr>
-                        <a:t>Volume (BFNET) R²</a:t>
+                        <a:t>QMD R²</a:t>
                       </a:r>
                       <a:endParaRPr lang="en-US" sz="1100" dirty="0">
                         <a:latin typeface="Calibri" charset="0"/>
@@ -3795,13 +3795,13 @@
                       <a:r>
                         <a:rPr lang="en-US" sz="1100" dirty="0">
                           <a:solidFill>
-                            <a:srgbClr val="000000"/>
+                            <a:srgbClr val="1E2A3A"/>
                           </a:solidFill>
                           <a:latin typeface="Calibri" pitchFamily="34" charset="0"/>
                           <a:ea typeface="Calibri" pitchFamily="34" charset="-122"/>
                           <a:cs typeface="Calibri" pitchFamily="34" charset="-120"/>
                         </a:rPr>
-                        <a:t>0.819</a:t>
+                        <a:t>0.354</a:t>
                       </a:r>
                       <a:endParaRPr lang="en-US" sz="1100" dirty="0">
                         <a:latin typeface="Calibri" charset="0"/>
@@ -3866,7 +3866,7 @@
                           <a:ea typeface="Calibri" pitchFamily="34" charset="-122"/>
                           <a:cs typeface="Calibri" pitchFamily="34" charset="-120"/>
                         </a:rPr>
-                        <a:t>0.858</a:t>
+                        <a:t>0.368</a:t>
                       </a:r>
                       <a:endParaRPr lang="en-US" sz="1100" dirty="0">
                         <a:latin typeface="Calibri" charset="0"/>
@@ -3931,7 +3931,7 @@
                           <a:ea typeface="Calibri" pitchFamily="34" charset="-122"/>
                           <a:cs typeface="Calibri" pitchFamily="34" charset="-120"/>
                         </a:rPr>
-                        <a:t>+4.8%</a:t>
+                        <a:t>+4.1%</a:t>
                       </a:r>
                       <a:endParaRPr lang="en-US" sz="1100" dirty="0">
                         <a:latin typeface="Calibri" charset="0"/>
@@ -3986,19 +3986,19 @@
                     <a:bodyPr/>
                     <a:lstStyle/>
                     <a:p>
-                      <a:pPr indent="0" marL="0">
+                      <a:pPr algn="ctr" indent="0" marL="0">
                         <a:buNone/>
                       </a:pPr>
                       <a:r>
                         <a:rPr lang="en-US" sz="1100" dirty="0">
                           <a:solidFill>
-                            <a:srgbClr val="000000"/>
+                            <a:srgbClr val="1E2A3A"/>
                           </a:solidFill>
                           <a:latin typeface="Calibri" pitchFamily="34" charset="0"/>
                           <a:ea typeface="Calibri" pitchFamily="34" charset="-122"/>
                           <a:cs typeface="Calibri" pitchFamily="34" charset="-120"/>
                         </a:rPr>
-                        <a:t>BA Equivalence (±10%)</a:t>
+                        <a:t>Volume (CFGRS) R²</a:t>
                       </a:r>
                       <a:endParaRPr lang="en-US" sz="1100" dirty="0">
                         <a:latin typeface="Calibri" charset="0"/>
@@ -4057,13 +4057,13 @@
                       <a:r>
                         <a:rPr lang="en-US" sz="1100" dirty="0">
                           <a:solidFill>
-                            <a:srgbClr val="000000"/>
+                            <a:srgbClr val="1E2A3A"/>
                           </a:solidFill>
                           <a:latin typeface="Calibri" pitchFamily="34" charset="0"/>
                           <a:ea typeface="Calibri" pitchFamily="34" charset="-122"/>
                           <a:cs typeface="Calibri" pitchFamily="34" charset="-120"/>
                         </a:rPr>
-                        <a:t>48.2%</a:t>
+                        <a:t>0.777</a:t>
                       </a:r>
                       <a:endParaRPr lang="en-US" sz="1100" dirty="0">
                         <a:latin typeface="Calibri" charset="0"/>
@@ -4128,7 +4128,7 @@
                           <a:ea typeface="Calibri" pitchFamily="34" charset="-122"/>
                           <a:cs typeface="Calibri" pitchFamily="34" charset="-120"/>
                         </a:rPr>
-                        <a:t>53.7%</a:t>
+                        <a:t>0.787</a:t>
                       </a:r>
                       <a:endParaRPr lang="en-US" sz="1100" dirty="0">
                         <a:latin typeface="Calibri" charset="0"/>
@@ -4193,7 +4193,7 @@
                           <a:ea typeface="Calibri" pitchFamily="34" charset="-122"/>
                           <a:cs typeface="Calibri" pitchFamily="34" charset="-120"/>
                         </a:rPr>
-                        <a:t>+5.5 pp</a:t>
+                        <a:t>+1.2%</a:t>
                       </a:r>
                       <a:endParaRPr lang="en-US" sz="1100" dirty="0">
                         <a:latin typeface="Calibri" charset="0"/>
@@ -4279,7 +4279,7 @@
                 <a:ea typeface="Calibri" pitchFamily="34" charset="-122"/>
                 <a:cs typeface="Calibri" pitchFamily="34" charset="-120"/>
               </a:rPr>
-              <a:t>Calibration improves all variants, but gains are modest — the architecture itself is the bottleneck.</a:t>
+              <a:t>Calibration improves all variants consistently. Gains are real but modest over 6.5-year projection horizons.</a:t>
             </a:r>
             <a:endParaRPr lang="en-US" sz="1200" dirty="0"/>
           </a:p>
@@ -4370,7 +4370,7 @@
                 <a:ea typeface="Georgia" pitchFamily="34" charset="-122"/>
                 <a:cs typeface="Georgia" pitchFamily="34" charset="-120"/>
               </a:rPr>
-              <a:t>Component Contributions &amp; Remaining Challenges</a:t>
+              <a:t>v3 Ablation: Component Contributions</a:t>
             </a:r>
             <a:endParaRPr lang="en-US" sz="2200" dirty="0"/>
           </a:p>
@@ -4507,7 +4507,7 @@
                 <a:ea typeface="Georgia" pitchFamily="34" charset="-122"/>
                 <a:cs typeface="Georgia" pitchFamily="34" charset="-120"/>
               </a:rPr>
-              <a:t>What’s Working</a:t>
+              <a:t>What Drives Improvement</a:t>
             </a:r>
             <a:endParaRPr lang="en-US" sz="1600" dirty="0"/>
           </a:p>
@@ -4549,7 +4549,7 @@
                 <a:ea typeface="Calibri" pitchFamily="34" charset="-122"/>
                 <a:cs typeface="Calibri" pitchFamily="34" charset="-120"/>
               </a:rPr>
-              <a:t>DG back-transformation fix</a:t>
+              <a:t>DG back-transformation fix (v2 → v3)</a:t>
             </a:r>
             <a:endParaRPr lang="en-US" sz="1200" dirty="0"/>
           </a:p>
@@ -4569,7 +4569,7 @@
                 <a:ea typeface="Calibri" pitchFamily="34" charset="-122"/>
                 <a:cs typeface="Calibri" pitchFamily="34" charset="-120"/>
               </a:rPr>
-              <a:t>Baskerville correction inflated predictions 24–86%. Switching to median prediction was the single biggest improvement.</a:t>
+              <a:t>Switching from Baskerville mean to median: BA RMSE 29.08 → 28.86. Baskerville correction inflated predictions 24–86% due to sigma 0.66–1.11.</a:t>
             </a:r>
             <a:endParaRPr lang="en-US" sz="1200" dirty="0"/>
           </a:p>
@@ -4589,7 +4589,7 @@
                 <a:ea typeface="Calibri" pitchFamily="34" charset="-122"/>
                 <a:cs typeface="Calibri" pitchFamily="34" charset="-120"/>
               </a:rPr>
-              <a:t>ClimateSI as site productivity proxy</a:t>
+              <a:t>Empirical ingrowth module</a:t>
             </a:r>
             <a:endParaRPr lang="en-US" sz="1200" dirty="0"/>
           </a:p>
@@ -4609,7 +4609,7 @@
                 <a:ea typeface="Calibri" pitchFamily="34" charset="-122"/>
                 <a:cs typeface="Calibri" pitchFamily="34" charset="-120"/>
               </a:rPr>
-              <a:t>ClimateNA-based site index covers 99.6% of FIA conditions. Reduces reliance on inconsistent FIA SICOND values.</a:t>
+              <a:t>Largest single component: removing ingrowth increases BA RMSE by 7.0%. Captures regeneration that default FVS misses over the 6.5-year window.</a:t>
             </a:r>
             <a:endParaRPr lang="en-US" sz="1200" dirty="0"/>
           </a:p>
@@ -4629,7 +4629,7 @@
                 <a:ea typeface="Calibri" pitchFamily="34" charset="-122"/>
                 <a:cs typeface="Calibri" pitchFamily="34" charset="-120"/>
               </a:rPr>
-              <a:t>Bayesian SDImax estimates</a:t>
+              <a:t>Bayesian DG calibration overall</a:t>
             </a:r>
             <a:endParaRPr lang="en-US" sz="1200" dirty="0"/>
           </a:p>
@@ -4646,7 +4646,7 @@
                 <a:ea typeface="Calibri" pitchFamily="34" charset="-122"/>
                 <a:cs typeface="Calibri" pitchFamily="34" charset="-120"/>
               </a:rPr>
-              <a:t>Data-driven carrying capacity averages 23% lower than FVS defaults. Asymmetric mortality onset at RDI=0.70 improves dense-stand projections.</a:t>
+              <a:t>Full model reduces BA RMSE 6.0% vs. baseline (DG only). Consistent improvement across all 20 benchmarked variants.</a:t>
             </a:r>
             <a:endParaRPr lang="en-US" sz="1200" dirty="0"/>
           </a:p>
@@ -4705,7 +4705,7 @@
                 <a:ea typeface="Georgia" pitchFamily="34" charset="-122"/>
                 <a:cs typeface="Georgia" pitchFamily="34" charset="-120"/>
               </a:rPr>
-              <a:t>Remaining Challenges</a:t>
+              <a:t>Limited Impact at Short Horizons</a:t>
             </a:r>
             <a:endParaRPr lang="en-US" sz="1600" dirty="0"/>
           </a:p>
@@ -4747,7 +4747,7 @@
                 <a:ea typeface="Calibri" pitchFamily="34" charset="-122"/>
                 <a:cs typeface="Calibri" pitchFamily="34" charset="-120"/>
               </a:rPr>
-              <a:t>Crown ratio model</a:t>
+              <a:t>ClimateSI (+0.03% when removed)</a:t>
             </a:r>
             <a:endParaRPr lang="en-US" sz="1200" dirty="0"/>
           </a:p>
@@ -4767,7 +4767,7 @@
                 <a:ea typeface="Calibri" pitchFamily="34" charset="-122"/>
                 <a:cs typeface="Calibri" pitchFamily="34" charset="-120"/>
               </a:rPr>
-              <a:t>R² = 0.13–0.38 across variants. Weakest calibrated component. Needs fundamentally different approach (lidar allometrics, nonlinear forms).</a:t>
+              <a:t>Site productivity proxy barely registers over 6.5-year projections. Expected to matter substantially at longer horizons where cumulative growth diverges.</a:t>
             </a:r>
             <a:endParaRPr lang="en-US" sz="1200" dirty="0"/>
           </a:p>
@@ -4787,7 +4787,7 @@
                 <a:ea typeface="Calibri" pitchFamily="34" charset="-122"/>
                 <a:cs typeface="Calibri" pitchFamily="34" charset="-120"/>
               </a:rPr>
-              <a:t>Site index inconsistency</a:t>
+              <a:t>Bayesian SDImax (−0.08% when removed)</a:t>
             </a:r>
             <a:endParaRPr lang="en-US" sz="1200" dirty="0"/>
           </a:p>
@@ -4807,7 +4807,7 @@
                 <a:ea typeface="Calibri" pitchFamily="34" charset="-122"/>
                 <a:cs typeface="Calibri" pitchFamily="34" charset="-120"/>
               </a:rPr>
-              <a:t>36 definitions for Douglas-fir alone. Even with ClimateSI, legacy SI confusion propagates through height growth.</a:t>
+              <a:t>Density-dependent mortality modifier (onset RDI=0.70, slope=0.5) rarely triggers in 6.5-year window. Critical for long-term stand dynamics.</a:t>
             </a:r>
             <a:endParaRPr lang="en-US" sz="1200" dirty="0"/>
           </a:p>
@@ -4827,7 +4827,7 @@
                 <a:ea typeface="Calibri" pitchFamily="34" charset="-122"/>
                 <a:cs typeface="Calibri" pitchFamily="34" charset="-120"/>
               </a:rPr>
-              <a:t>Ingrowth is empirical only</a:t>
+              <a:t>Crown ratio model (R² = 0.13–0.38)</a:t>
             </a:r>
             <a:endParaRPr lang="en-US" sz="1200" dirty="0"/>
           </a:p>
@@ -4844,7 +4844,7 @@
                 <a:ea typeface="Calibri" pitchFamily="34" charset="-122"/>
                 <a:cs typeface="Calibri" pitchFamily="34" charset="-120"/>
               </a:rPr>
-              <a:t>Adequate for 5–15 year projections but not climate-sensitive. Cannot capture shifting species composition.</a:t>
+              <a:t>Weakest calibrated component. Needs fundamental redesign (lidar allometrics, nonlinear forms) for the CONUS variant.</a:t>
             </a:r>
             <a:endParaRPr lang="en-US" sz="1200" dirty="0"/>
           </a:p>
@@ -4922,7 +4922,7 @@
                 <a:ea typeface="Calibri" pitchFamily="34" charset="-122"/>
                 <a:cs typeface="Calibri" pitchFamily="34" charset="-120"/>
               </a:rPr>
-              <a:t>The 22-variant architecture constrains how far calibration alone can take us. Many of these challenges are structural and require a unified national framework to solve properly.</a:t>
+              <a:t>Short-term benchmarks validate the pipeline, but the real test is long-term projection. ClimateSI and SDImax will diverge over 50–100 year horizons. The 22-variant architecture constrains how far calibration can take us.</a:t>
             </a:r>
             <a:endParaRPr lang="en-US" sz="1200" dirty="0"/>
           </a:p>
@@ -5253,7 +5253,7 @@
                 <a:ea typeface="Calibri" pitchFamily="34" charset="-122"/>
                 <a:cs typeface="Calibri" pitchFamily="34" charset="-120"/>
               </a:rPr>
-              <a:t>Move from variable-interval projection to annualized increment equations. Standardize across all measurement periods. Eliminate the remeasurement-length bias.</a:t>
+              <a:t>Cao/Weiskittel annualization method applied to all FIA remeasurement combinations. Eliminates measurement-period bias embedded in current Wykoff DDS models.</a:t>
             </a:r>
             <a:endParaRPr lang="en-US" sz="1050" dirty="0"/>
           </a:p>
@@ -5337,7 +5337,7 @@
                 <a:ea typeface="Georgia" pitchFamily="34" charset="-122"/>
                 <a:cs typeface="Georgia" pitchFamily="34" charset="-120"/>
               </a:rPr>
-              <a:t>New Equation Forms</a:t>
+              <a:t>ORGANON-Family Equations</a:t>
             </a:r>
             <a:endParaRPr lang="en-US" sz="1400" dirty="0"/>
           </a:p>
@@ -5376,7 +5376,7 @@
                 <a:ea typeface="Calibri" pitchFamily="34" charset="-122"/>
                 <a:cs typeface="Calibri" pitchFamily="34" charset="-120"/>
               </a:rPr>
-              <a:t>Replace Wykoff ln(DDS) with biologically consistent forms (e.g., ORGANON-family). Better behavior at diameter extremes. Crown ratio and height growth redesigned from scratch.</a:t>
+              <a:t>Biologically consistent forms (Zumrawi &amp; Hann 1993). Already fitted to 84 CONUS species (3.48M records). No log-scale back-transformation needed.</a:t>
             </a:r>
             <a:endParaRPr lang="en-US" sz="1050" dirty="0"/>
           </a:p>
@@ -5499,7 +5499,7 @@
                 <a:ea typeface="Calibri" pitchFamily="34" charset="-122"/>
                 <a:cs typeface="Calibri" pitchFamily="34" charset="-120"/>
               </a:rPr>
-              <a:t>Ecoregion partial pooling replaces hard variant boundaries. Climate covariates capture productivity gradients. No more discontinuities at arbitrary borders.</a:t>
+              <a:t>Nested random effects (ecoregion within species) via Bayesian hierarchical models. Smooth transitions replace hard variant boundaries.</a:t>
             </a:r>
             <a:endParaRPr lang="en-US" sz="1050" dirty="0"/>
           </a:p>
@@ -5583,7 +5583,7 @@
                 <a:ea typeface="Georgia" pitchFamily="34" charset="-122"/>
                 <a:cs typeface="Georgia" pitchFamily="34" charset="-120"/>
               </a:rPr>
-              <a:t>Species by FIA SPCD</a:t>
+              <a:t>Universal Species Coding</a:t>
             </a:r>
             <a:endParaRPr lang="en-US" sz="1400" dirty="0"/>
           </a:p>
@@ -5622,7 +5622,7 @@
                 <a:ea typeface="Calibri" pitchFamily="34" charset="-122"/>
                 <a:cs typeface="Calibri" pitchFamily="34" charset="-120"/>
               </a:rPr>
-              <a:t>Universal species coding. One red maple model across all regions with regional random effects. Data-driven coverage for 84+ species with ≥5,000 FIA observations each.</a:t>
+              <a:t>FIA SPCD-based, one model per species across all regions. Partial pooling handles data-sparse species at range edges naturally.</a:t>
             </a:r>
             <a:endParaRPr lang="en-US" sz="1050" dirty="0"/>
           </a:p>

</xml_diff>